<commit_message>
Simplify poster and add benefits to pitch per supervisor feedback
Builds on the team's edited poster (2x2 problem cards, "before" picture).
Cuts sprint descriptions, process chips, architecture and extra stats,
adds a "What schools gain" panel, and adds the same benefits to the pitch.
PowerPoint files are now the master copies; PDFs exported from them.

Co-Authored-By: Claude Opus 5.5 <noreply@anthropic.com>
</commit_message>
<xml_diff>
--- a/docs/poster/pptx/UG_ICT_P01_pitch.pptx
+++ b/docs/poster/pptx/UG_ICT_P01_pitch.pptx
@@ -935,7 +935,7 @@
         </p:blipFill>
         <p:spPr>
           <a:xfrm>
-            <a:off x="495300" y="361950"/>
+            <a:off x="495300" y="323850"/>
             <a:ext cx="823913" cy="285750"/>
           </a:xfrm>
           <a:prstGeom prst="rect">
@@ -951,7 +951,7 @@
         </p:nvSpPr>
         <p:spPr>
           <a:xfrm>
-            <a:off x="1390650" y="381000"/>
+            <a:off x="1390650" y="342900"/>
             <a:ext cx="152400" cy="247650"/>
           </a:xfrm>
           <a:prstGeom prst="rect">
@@ -998,7 +998,7 @@
         </p:blipFill>
         <p:spPr>
           <a:xfrm>
-            <a:off x="1581150" y="390525"/>
+            <a:off x="1581150" y="352425"/>
             <a:ext cx="510540" cy="228600"/>
           </a:xfrm>
           <a:prstGeom prst="rect">
@@ -1014,8 +1014,8 @@
         </p:nvSpPr>
         <p:spPr>
           <a:xfrm>
-            <a:off x="476250" y="762000"/>
-            <a:ext cx="6343650" cy="571500"/>
+            <a:off x="476250" y="685800"/>
+            <a:ext cx="6343650" cy="533400"/>
           </a:xfrm>
           <a:prstGeom prst="rect">
             <a:avLst/>
@@ -1031,7 +1031,7 @@
               <a:buNone/>
             </a:pPr>
             <a:r>
-              <a:rPr lang="en-US" sz="4200" b="1" spc="-100" kern="0" dirty="0">
+              <a:rPr lang="en-US" sz="4000" b="1" spc="-100" kern="0" dirty="0">
                 <a:solidFill>
                   <a:srgbClr val="262626"/>
                 </a:solidFill>
@@ -1045,7 +1045,7 @@
               <a:buNone/>
             </a:pPr>
             <a:r>
-              <a:rPr lang="en-US" sz="4200" b="1" spc="-100" kern="0" dirty="0">
+              <a:rPr lang="en-US" sz="4000" b="1" spc="-100" kern="0" dirty="0">
                 <a:solidFill>
                   <a:srgbClr val="009CA6"/>
                 </a:solidFill>
@@ -1055,7 +1055,7 @@
               </a:rPr>
               <a:t>Inventory</a:t>
             </a:r>
-            <a:endParaRPr lang="en-US" sz="4200" dirty="0"/>
+            <a:endParaRPr lang="en-US" sz="4000" dirty="0"/>
           </a:p>
         </p:txBody>
       </p:sp>
@@ -1067,8 +1067,8 @@
         </p:nvSpPr>
         <p:spPr>
           <a:xfrm>
-            <a:off x="495300" y="1390650"/>
-            <a:ext cx="6343650" cy="552450"/>
+            <a:off x="495300" y="1257300"/>
+            <a:ext cx="6343650" cy="476250"/>
           </a:xfrm>
           <a:prstGeom prst="rect">
             <a:avLst/>
@@ -1084,7 +1084,7 @@
               <a:buNone/>
             </a:pPr>
             <a:r>
-              <a:rPr lang="en-US" sz="1600" b="1" dirty="0">
+              <a:rPr lang="en-US" sz="1500" b="1" dirty="0">
                 <a:solidFill>
                   <a:srgbClr val="7B57CB"/>
                 </a:solidFill>
@@ -1094,7 +1094,7 @@
               </a:rPr>
               <a:t>Stop asking "who has the projector?" Know where every school asset is, who has it, and when it's due back.</a:t>
             </a:r>
-            <a:endParaRPr lang="en-US" sz="1600" dirty="0"/>
+            <a:endParaRPr lang="en-US" sz="1500" dirty="0"/>
           </a:p>
         </p:txBody>
       </p:sp>
@@ -1106,12 +1106,12 @@
         </p:nvSpPr>
         <p:spPr>
           <a:xfrm>
-            <a:off x="495300" y="2095500"/>
-            <a:ext cx="6343650" cy="762000"/>
+            <a:off x="495300" y="1847850"/>
+            <a:ext cx="6343650" cy="666750"/>
           </a:xfrm>
           <a:prstGeom prst="roundRect">
             <a:avLst>
-              <a:gd name="adj" fmla="val 12500"/>
+              <a:gd name="adj" fmla="val 14286"/>
             </a:avLst>
           </a:prstGeom>
           <a:solidFill>
@@ -1133,12 +1133,12 @@
         </p:nvSpPr>
         <p:spPr>
           <a:xfrm>
-            <a:off x="495300" y="2095500"/>
-            <a:ext cx="1428750" cy="762000"/>
+            <a:off x="495300" y="1847850"/>
+            <a:ext cx="1428750" cy="666750"/>
           </a:xfrm>
           <a:prstGeom prst="roundRect">
             <a:avLst>
-              <a:gd name="adj" fmla="val 12500"/>
+              <a:gd name="adj" fmla="val 14286"/>
             </a:avLst>
           </a:prstGeom>
           <a:solidFill>
@@ -1160,8 +1160,8 @@
         </p:nvSpPr>
         <p:spPr>
           <a:xfrm>
-            <a:off x="1809750" y="2095500"/>
-            <a:ext cx="114300" cy="762000"/>
+            <a:off x="1809750" y="1847850"/>
+            <a:ext cx="114300" cy="666750"/>
           </a:xfrm>
           <a:prstGeom prst="rect">
             <a:avLst/>
@@ -1185,8 +1185,8 @@
         </p:nvSpPr>
         <p:spPr>
           <a:xfrm>
-            <a:off x="628650" y="2095500"/>
-            <a:ext cx="1238250" cy="762000"/>
+            <a:off x="628650" y="1847850"/>
+            <a:ext cx="1238250" cy="666750"/>
           </a:xfrm>
           <a:prstGeom prst="rect">
             <a:avLst/>
@@ -1224,8 +1224,8 @@
         </p:nvSpPr>
         <p:spPr>
           <a:xfrm>
-            <a:off x="2057400" y="2095500"/>
-            <a:ext cx="4667250" cy="762000"/>
+            <a:off x="2057400" y="1847850"/>
+            <a:ext cx="4667250" cy="666750"/>
           </a:xfrm>
           <a:prstGeom prst="rect">
             <a:avLst/>
@@ -1252,7 +1252,7 @@
                 <a:ea typeface="Arial" pitchFamily="34" charset="-122"/>
                 <a:cs typeface="Arial" pitchFamily="34" charset="-120"/>
               </a:rPr>
-              <a:t>Schools track thousands of laptops, lab kits and instruments with spreadsheets, paper sign-out sheets and memory, so items go missing and stock expires unnoticed.</a:t>
+              <a:t>Schools track laptops, lab kits and instruments with spreadsheets, paper and memory, so items go missing and stock expires unnoticed.</a:t>
             </a:r>
             <a:endParaRPr lang="en-US" sz="1200" dirty="0"/>
           </a:p>
@@ -1266,12 +1266,12 @@
         </p:nvSpPr>
         <p:spPr>
           <a:xfrm>
-            <a:off x="495300" y="2962275"/>
-            <a:ext cx="6343650" cy="762000"/>
+            <a:off x="495300" y="2609850"/>
+            <a:ext cx="6343650" cy="666750"/>
           </a:xfrm>
           <a:prstGeom prst="roundRect">
             <a:avLst>
-              <a:gd name="adj" fmla="val 12500"/>
+              <a:gd name="adj" fmla="val 14286"/>
             </a:avLst>
           </a:prstGeom>
           <a:solidFill>
@@ -1293,12 +1293,12 @@
         </p:nvSpPr>
         <p:spPr>
           <a:xfrm>
-            <a:off x="495300" y="2962275"/>
-            <a:ext cx="1428750" cy="762000"/>
+            <a:off x="495300" y="2609850"/>
+            <a:ext cx="1428750" cy="666750"/>
           </a:xfrm>
           <a:prstGeom prst="roundRect">
             <a:avLst>
-              <a:gd name="adj" fmla="val 12500"/>
+              <a:gd name="adj" fmla="val 14286"/>
             </a:avLst>
           </a:prstGeom>
           <a:solidFill>
@@ -1320,8 +1320,8 @@
         </p:nvSpPr>
         <p:spPr>
           <a:xfrm>
-            <a:off x="1809750" y="2962275"/>
-            <a:ext cx="114300" cy="762000"/>
+            <a:off x="1809750" y="2609850"/>
+            <a:ext cx="114300" cy="666750"/>
           </a:xfrm>
           <a:prstGeom prst="rect">
             <a:avLst/>
@@ -1345,8 +1345,8 @@
         </p:nvSpPr>
         <p:spPr>
           <a:xfrm>
-            <a:off x="628650" y="2962275"/>
-            <a:ext cx="1238250" cy="762000"/>
+            <a:off x="628650" y="2609850"/>
+            <a:ext cx="1238250" cy="666750"/>
           </a:xfrm>
           <a:prstGeom prst="rect">
             <a:avLst/>
@@ -1384,8 +1384,8 @@
         </p:nvSpPr>
         <p:spPr>
           <a:xfrm>
-            <a:off x="2057400" y="2962275"/>
-            <a:ext cx="4667250" cy="762000"/>
+            <a:off x="2057400" y="2609850"/>
+            <a:ext cx="4667250" cy="666750"/>
           </a:xfrm>
           <a:prstGeom prst="rect">
             <a:avLst/>
@@ -1412,7 +1412,7 @@
                 <a:ea typeface="Arial" pitchFamily="34" charset="-122"/>
                 <a:cs typeface="Arial" pitchFamily="34" charset="-120"/>
               </a:rPr>
-              <a:t>An inventory back end for Civica's Daymap platform: items and individual units, loans and returns, custom fields, tags, expiry tracking and search.</a:t>
+              <a:t>An inventory system for Civica's Daymap platform: every item and unit, loans and returns, custom fields, tags, expiry alerts and search.</a:t>
             </a:r>
             <a:endParaRPr lang="en-US" sz="1200" dirty="0"/>
           </a:p>
@@ -1426,39 +1426,12 @@
         </p:nvSpPr>
         <p:spPr>
           <a:xfrm>
-            <a:off x="495300" y="3819525"/>
-            <a:ext cx="6343650" cy="647700"/>
+            <a:off x="495300" y="3371850"/>
+            <a:ext cx="6343650" cy="1524000"/>
           </a:xfrm>
           <a:prstGeom prst="roundRect">
             <a:avLst>
-              <a:gd name="adj" fmla="val 14706"/>
-            </a:avLst>
-          </a:prstGeom>
-          <a:solidFill>
-            <a:srgbClr val="F2F4F5"/>
-          </a:solidFill>
-          <a:ln w="12700">
-            <a:solidFill>
-              <a:srgbClr val="F2F4F5"/>
-            </a:solidFill>
-            <a:prstDash val="solid"/>
-          </a:ln>
-        </p:spPr>
-      </p:sp>
-      <p:sp>
-        <p:nvSpPr>
-          <p:cNvPr id="20" name="Shape 16"/>
-          <p:cNvSpPr/>
-          <p:nvPr/>
-        </p:nvSpPr>
-        <p:spPr>
-          <a:xfrm>
-            <a:off x="495300" y="3819525"/>
-            <a:ext cx="1428750" cy="647700"/>
-          </a:xfrm>
-          <a:prstGeom prst="roundRect">
-            <a:avLst>
-              <a:gd name="adj" fmla="val 14706"/>
+              <a:gd name="adj" fmla="val 6250"/>
             </a:avLst>
           </a:prstGeom>
           <a:solidFill>
@@ -1474,39 +1447,14 @@
       </p:sp>
       <p:sp>
         <p:nvSpPr>
-          <p:cNvPr id="21" name="Shape 17"/>
-          <p:cNvSpPr/>
-          <p:nvPr/>
-        </p:nvSpPr>
-        <p:spPr>
-          <a:xfrm>
-            <a:off x="1809750" y="3819525"/>
-            <a:ext cx="114300" cy="647700"/>
-          </a:xfrm>
-          <a:prstGeom prst="rect">
-            <a:avLst/>
-          </a:prstGeom>
-          <a:solidFill>
-            <a:srgbClr val="7B57CB"/>
-          </a:solidFill>
-          <a:ln w="12700">
-            <a:solidFill>
-              <a:srgbClr val="7B57CB"/>
-            </a:solidFill>
-            <a:prstDash val="solid"/>
-          </a:ln>
-        </p:spPr>
-      </p:sp>
-      <p:sp>
-        <p:nvSpPr>
-          <p:cNvPr id="22" name="WHY IT MATTERS"/>
+          <p:cNvPr id="20" name="Benefits heading"/>
           <p:cNvSpPr txBox="1"/>
           <p:nvPr/>
         </p:nvSpPr>
         <p:spPr>
           <a:xfrm>
-            <a:off x="628650" y="3819525"/>
-            <a:ext cx="1238250" cy="647700"/>
+            <a:off x="628650" y="3448050"/>
+            <a:ext cx="3810000" cy="247650"/>
           </a:xfrm>
           <a:prstGeom prst="rect">
             <a:avLst/>
@@ -1522,7 +1470,7 @@
               <a:buNone/>
             </a:pPr>
             <a:r>
-              <a:rPr lang="en-US" sz="1150" b="1" spc="100" kern="0" dirty="0">
+              <a:rPr lang="en-US" sz="1300" b="1" spc="100" kern="0" dirty="0">
                 <a:solidFill>
                   <a:srgbClr val="FFFFFF"/>
                 </a:solidFill>
@@ -1530,22 +1478,46 @@
                 <a:ea typeface="Arial" pitchFamily="34" charset="-122"/>
                 <a:cs typeface="Arial" pitchFamily="34" charset="-120"/>
               </a:rPr>
-              <a:t>WHY IT MATTERS</a:t>
-            </a:r>
-            <a:endParaRPr lang="en-US" sz="1150" dirty="0"/>
-          </a:p>
-        </p:txBody>
-      </p:sp>
-      <p:sp>
-        <p:nvSpPr>
-          <p:cNvPr id="23" name="Text 19"/>
+              <a:t>WHAT SCHOOLS GAIN</a:t>
+            </a:r>
+            <a:endParaRPr lang="en-US" sz="1300" dirty="0"/>
+          </a:p>
+        </p:txBody>
+      </p:sp>
+      <p:sp>
+        <p:nvSpPr>
+          <p:cNvPr id="21" name="Shape 17"/>
+          <p:cNvSpPr/>
+          <p:nvPr/>
+        </p:nvSpPr>
+        <p:spPr>
+          <a:xfrm>
+            <a:off x="628650" y="3752850"/>
+            <a:ext cx="1962150" cy="1028700"/>
+          </a:xfrm>
+          <a:prstGeom prst="roundRect">
+            <a:avLst>
+              <a:gd name="adj" fmla="val 7407"/>
+            </a:avLst>
+          </a:prstGeom>
+          <a:solidFill>
+            <a:srgbClr val="FFFFFF">
+              <a:alpha val="15000"/>
+            </a:srgbClr>
+          </a:solidFill>
+          <a:ln/>
+        </p:spPr>
+      </p:sp>
+      <p:sp>
+        <p:nvSpPr>
+          <p:cNvPr id="22" name="Benefit: Save staff time"/>
           <p:cNvSpPr txBox="1"/>
           <p:nvPr/>
         </p:nvSpPr>
         <p:spPr>
           <a:xfrm>
-            <a:off x="2057400" y="3819525"/>
-            <a:ext cx="4667250" cy="647700"/>
+            <a:off x="723900" y="3829050"/>
+            <a:ext cx="1771650" cy="895350"/>
           </a:xfrm>
           <a:prstGeom prst="rect">
             <a:avLst/>
@@ -1554,44 +1526,254 @@
           <a:ln/>
         </p:spPr>
         <p:txBody>
-          <a:bodyPr wrap="square" lIns="0" tIns="0" rIns="0" bIns="0" rtlCol="0" anchor="ctr"/>
+          <a:bodyPr wrap="square" lIns="0" tIns="0" rIns="0" bIns="0" rtlCol="0" anchor="t"/>
           <a:lstStyle/>
           <a:p>
             <a:pPr indent="0" marL="0">
               <a:lnSpc>
-                <a:spcPct val="105000"/>
+                <a:spcPct val="110000"/>
               </a:lnSpc>
+              <a:spcAft>
+                <a:spcPts val="400"/>
+              </a:spcAft>
               <a:buNone/>
             </a:pPr>
             <a:r>
-              <a:rPr lang="en-US" sz="1200" dirty="0">
+              <a:rPr lang="en-US" sz="1350" b="1" dirty="0">
                 <a:solidFill>
-                  <a:srgbClr val="262626"/>
+                  <a:srgbClr val="FFFFFF"/>
                 </a:solidFill>
                 <a:latin typeface="Arial" pitchFamily="34" charset="0"/>
                 <a:ea typeface="Arial" pitchFamily="34" charset="-122"/>
                 <a:cs typeface="Arial" pitchFamily="34" charset="-120"/>
               </a:rPr>
-              <a:t>Less time chasing equipment, fewer lost and expired items, and one trusted record of everything a school owns.</a:t>
-            </a:r>
-            <a:endParaRPr lang="en-US" sz="1200" dirty="0"/>
-          </a:p>
-        </p:txBody>
-      </p:sp>
-      <p:sp>
-        <p:nvSpPr>
-          <p:cNvPr id="24" name="Shape 20"/>
+              <a:t>Save staff time</a:t>
+            </a:r>
+            <a:endParaRPr lang="en-US" sz="1350" dirty="0"/>
+          </a:p>
+          <a:p>
+            <a:pPr indent="0" marL="0">
+              <a:lnSpc>
+                <a:spcPct val="110000"/>
+              </a:lnSpc>
+              <a:spcAft>
+                <a:spcPts val="400"/>
+              </a:spcAft>
+              <a:buNone/>
+            </a:pPr>
+            <a:r>
+              <a:rPr lang="en-US" sz="1150" dirty="0">
+                <a:solidFill>
+                  <a:srgbClr val="FFFFFF"/>
+                </a:solidFill>
+                <a:latin typeface="Arial" pitchFamily="34" charset="0"/>
+                <a:ea typeface="Arial" pitchFamily="34" charset="-122"/>
+                <a:cs typeface="Arial" pitchFamily="34" charset="-120"/>
+              </a:rPr>
+              <a:t>See who has any item and when it's due back.</a:t>
+            </a:r>
+            <a:endParaRPr lang="en-US" sz="1350" dirty="0"/>
+          </a:p>
+        </p:txBody>
+      </p:sp>
+      <p:sp>
+        <p:nvSpPr>
+          <p:cNvPr id="23" name="Shape 19"/>
           <p:cNvSpPr/>
           <p:nvPr/>
         </p:nvSpPr>
         <p:spPr>
           <a:xfrm>
-            <a:off x="495300" y="4600575"/>
-            <a:ext cx="2051050" cy="1371600"/>
+            <a:off x="2686050" y="3752850"/>
+            <a:ext cx="1962150" cy="1028700"/>
           </a:xfrm>
           <a:prstGeom prst="roundRect">
             <a:avLst>
-              <a:gd name="adj" fmla="val 6944"/>
+              <a:gd name="adj" fmla="val 7407"/>
+            </a:avLst>
+          </a:prstGeom>
+          <a:solidFill>
+            <a:srgbClr val="FFFFFF">
+              <a:alpha val="15000"/>
+            </a:srgbClr>
+          </a:solidFill>
+          <a:ln/>
+        </p:spPr>
+      </p:sp>
+      <p:sp>
+        <p:nvSpPr>
+          <p:cNvPr id="24" name="Benefit: Fewer losses"/>
+          <p:cNvSpPr txBox="1"/>
+          <p:nvPr/>
+        </p:nvSpPr>
+        <p:spPr>
+          <a:xfrm>
+            <a:off x="2781300" y="3829050"/>
+            <a:ext cx="1771650" cy="895350"/>
+          </a:xfrm>
+          <a:prstGeom prst="rect">
+            <a:avLst/>
+          </a:prstGeom>
+          <a:noFill/>
+          <a:ln/>
+        </p:spPr>
+        <p:txBody>
+          <a:bodyPr wrap="square" lIns="0" tIns="0" rIns="0" bIns="0" rtlCol="0" anchor="t"/>
+          <a:lstStyle/>
+          <a:p>
+            <a:pPr indent="0" marL="0">
+              <a:lnSpc>
+                <a:spcPct val="110000"/>
+              </a:lnSpc>
+              <a:spcAft>
+                <a:spcPts val="400"/>
+              </a:spcAft>
+              <a:buNone/>
+            </a:pPr>
+            <a:r>
+              <a:rPr lang="en-US" sz="1350" b="1" dirty="0">
+                <a:solidFill>
+                  <a:srgbClr val="FFFFFF"/>
+                </a:solidFill>
+                <a:latin typeface="Arial" pitchFamily="34" charset="0"/>
+                <a:ea typeface="Arial" pitchFamily="34" charset="-122"/>
+                <a:cs typeface="Arial" pitchFamily="34" charset="-120"/>
+              </a:rPr>
+              <a:t>Fewer losses</a:t>
+            </a:r>
+            <a:endParaRPr lang="en-US" sz="1350" dirty="0"/>
+          </a:p>
+          <a:p>
+            <a:pPr indent="0" marL="0">
+              <a:lnSpc>
+                <a:spcPct val="110000"/>
+              </a:lnSpc>
+              <a:spcAft>
+                <a:spcPts val="400"/>
+              </a:spcAft>
+              <a:buNone/>
+            </a:pPr>
+            <a:r>
+              <a:rPr lang="en-US" sz="1150" dirty="0">
+                <a:solidFill>
+                  <a:srgbClr val="FFFFFF"/>
+                </a:solidFill>
+                <a:latin typeface="Arial" pitchFamily="34" charset="0"/>
+                <a:ea typeface="Arial" pitchFamily="34" charset="-122"/>
+                <a:cs typeface="Arial" pitchFamily="34" charset="-120"/>
+              </a:rPr>
+              <a:t>Overdue loans and expiring stock are flagged early.</a:t>
+            </a:r>
+            <a:endParaRPr lang="en-US" sz="1350" dirty="0"/>
+          </a:p>
+        </p:txBody>
+      </p:sp>
+      <p:sp>
+        <p:nvSpPr>
+          <p:cNvPr id="25" name="Shape 21"/>
+          <p:cNvSpPr/>
+          <p:nvPr/>
+        </p:nvSpPr>
+        <p:spPr>
+          <a:xfrm>
+            <a:off x="4743450" y="3752850"/>
+            <a:ext cx="1962150" cy="1028700"/>
+          </a:xfrm>
+          <a:prstGeom prst="roundRect">
+            <a:avLst>
+              <a:gd name="adj" fmla="val 7407"/>
+            </a:avLst>
+          </a:prstGeom>
+          <a:solidFill>
+            <a:srgbClr val="FFFFFF">
+              <a:alpha val="15000"/>
+            </a:srgbClr>
+          </a:solidFill>
+          <a:ln/>
+        </p:spPr>
+      </p:sp>
+      <p:sp>
+        <p:nvSpPr>
+          <p:cNvPr id="26" name="Benefit: One trusted record"/>
+          <p:cNvSpPr txBox="1"/>
+          <p:nvPr/>
+        </p:nvSpPr>
+        <p:spPr>
+          <a:xfrm>
+            <a:off x="4838700" y="3829050"/>
+            <a:ext cx="1771650" cy="895350"/>
+          </a:xfrm>
+          <a:prstGeom prst="rect">
+            <a:avLst/>
+          </a:prstGeom>
+          <a:noFill/>
+          <a:ln/>
+        </p:spPr>
+        <p:txBody>
+          <a:bodyPr wrap="square" lIns="0" tIns="0" rIns="0" bIns="0" rtlCol="0" anchor="t"/>
+          <a:lstStyle/>
+          <a:p>
+            <a:pPr indent="0" marL="0">
+              <a:lnSpc>
+                <a:spcPct val="110000"/>
+              </a:lnSpc>
+              <a:spcAft>
+                <a:spcPts val="400"/>
+              </a:spcAft>
+              <a:buNone/>
+            </a:pPr>
+            <a:r>
+              <a:rPr lang="en-US" sz="1350" b="1" dirty="0">
+                <a:solidFill>
+                  <a:srgbClr val="FFFFFF"/>
+                </a:solidFill>
+                <a:latin typeface="Arial" pitchFamily="34" charset="0"/>
+                <a:ea typeface="Arial" pitchFamily="34" charset="-122"/>
+                <a:cs typeface="Arial" pitchFamily="34" charset="-120"/>
+              </a:rPr>
+              <a:t>One trusted record</a:t>
+            </a:r>
+            <a:endParaRPr lang="en-US" sz="1350" dirty="0"/>
+          </a:p>
+          <a:p>
+            <a:pPr indent="0" marL="0">
+              <a:lnSpc>
+                <a:spcPct val="110000"/>
+              </a:lnSpc>
+              <a:spcAft>
+                <a:spcPts val="400"/>
+              </a:spcAft>
+              <a:buNone/>
+            </a:pPr>
+            <a:r>
+              <a:rPr lang="en-US" sz="1150" dirty="0">
+                <a:solidFill>
+                  <a:srgbClr val="FFFFFF"/>
+                </a:solidFill>
+                <a:latin typeface="Arial" pitchFamily="34" charset="0"/>
+                <a:ea typeface="Arial" pitchFamily="34" charset="-122"/>
+                <a:cs typeface="Arial" pitchFamily="34" charset="-120"/>
+              </a:rPr>
+              <a:t>Every item on every campus, set up the way each school works.</a:t>
+            </a:r>
+            <a:endParaRPr lang="en-US" sz="1350" dirty="0"/>
+          </a:p>
+        </p:txBody>
+      </p:sp>
+      <p:sp>
+        <p:nvSpPr>
+          <p:cNvPr id="27" name="Shape 23"/>
+          <p:cNvSpPr/>
+          <p:nvPr/>
+        </p:nvSpPr>
+        <p:spPr>
+          <a:xfrm>
+            <a:off x="495300" y="5010150"/>
+            <a:ext cx="2051050" cy="990600"/>
+          </a:xfrm>
+          <a:prstGeom prst="roundRect">
+            <a:avLst>
+              <a:gd name="adj" fmla="val 9615"/>
             </a:avLst>
           </a:prstGeom>
           <a:solidFill>
@@ -1607,14 +1789,14 @@
       </p:sp>
       <p:sp>
         <p:nvSpPr>
-          <p:cNvPr id="25" name="Highlight 40"/>
+          <p:cNvPr id="28" name="Highlight 40"/>
           <p:cNvSpPr txBox="1"/>
           <p:nvPr/>
         </p:nvSpPr>
         <p:spPr>
           <a:xfrm>
-            <a:off x="628650" y="4714875"/>
-            <a:ext cx="1784350" cy="1181100"/>
+            <a:off x="628650" y="5105400"/>
+            <a:ext cx="1784350" cy="819150"/>
           </a:xfrm>
           <a:prstGeom prst="rect">
             <a:avLst/>
@@ -1653,7 +1835,7 @@
               <a:buNone/>
             </a:pPr>
             <a:r>
-              <a:rPr lang="en-US" sz="1100" dirty="0">
+              <a:rPr lang="en-US" sz="1150" dirty="0">
                 <a:solidFill>
                   <a:srgbClr val="DDDDDD"/>
                 </a:solidFill>
@@ -1661,7 +1843,7 @@
                 <a:ea typeface="Arial" pitchFamily="34" charset="-122"/>
                 <a:cs typeface="Arial" pitchFamily="34" charset="-120"/>
               </a:rPr>
-              <a:t>REST endpoints covering the full item lifecycle</a:t>
+              <a:t>REST endpoints across the full item lifecycle</a:t>
             </a:r>
             <a:endParaRPr lang="en-US" sz="2200" dirty="0"/>
           </a:p>
@@ -1669,18 +1851,18 @@
       </p:sp>
       <p:sp>
         <p:nvSpPr>
-          <p:cNvPr id="26" name="Shape 22"/>
+          <p:cNvPr id="29" name="Shape 25"/>
           <p:cNvSpPr/>
           <p:nvPr/>
         </p:nvSpPr>
         <p:spPr>
           <a:xfrm>
-            <a:off x="2641600" y="4600575"/>
-            <a:ext cx="2051050" cy="1371600"/>
+            <a:off x="2641600" y="5010150"/>
+            <a:ext cx="2051050" cy="990600"/>
           </a:xfrm>
           <a:prstGeom prst="roundRect">
             <a:avLst>
-              <a:gd name="adj" fmla="val 6944"/>
+              <a:gd name="adj" fmla="val 9615"/>
             </a:avLst>
           </a:prstGeom>
           <a:solidFill>
@@ -1696,14 +1878,14 @@
       </p:sp>
       <p:sp>
         <p:nvSpPr>
-          <p:cNvPr id="27" name="Highlight 105"/>
+          <p:cNvPr id="30" name="Highlight 105"/>
           <p:cNvSpPr txBox="1"/>
           <p:nvPr/>
         </p:nvSpPr>
         <p:spPr>
           <a:xfrm>
-            <a:off x="2774950" y="4714875"/>
-            <a:ext cx="1784350" cy="1181100"/>
+            <a:off x="2774950" y="5105400"/>
+            <a:ext cx="1784350" cy="819150"/>
           </a:xfrm>
           <a:prstGeom prst="rect">
             <a:avLst/>
@@ -1742,7 +1924,7 @@
               <a:buNone/>
             </a:pPr>
             <a:r>
-              <a:rPr lang="en-US" sz="1100" dirty="0">
+              <a:rPr lang="en-US" sz="1150" dirty="0">
                 <a:solidFill>
                   <a:srgbClr val="DDDDDD"/>
                 </a:solidFill>
@@ -1750,7 +1932,7 @@
                 <a:ea typeface="Arial" pitchFamily="34" charset="-122"/>
                 <a:cs typeface="Arial" pitchFamily="34" charset="-120"/>
               </a:rPr>
-              <a:t>passing unit tests across controllers and repositories</a:t>
+              <a:t>passing unit tests</a:t>
             </a:r>
             <a:endParaRPr lang="en-US" sz="2200" dirty="0"/>
           </a:p>
@@ -1758,18 +1940,18 @@
       </p:sp>
       <p:sp>
         <p:nvSpPr>
-          <p:cNvPr id="28" name="Shape 24"/>
+          <p:cNvPr id="31" name="Shape 27"/>
           <p:cNvSpPr/>
           <p:nvPr/>
         </p:nvSpPr>
         <p:spPr>
           <a:xfrm>
-            <a:off x="4787900" y="4600575"/>
-            <a:ext cx="2051050" cy="1371600"/>
+            <a:off x="4787900" y="5010150"/>
+            <a:ext cx="2051050" cy="990600"/>
           </a:xfrm>
           <a:prstGeom prst="roundRect">
             <a:avLst>
-              <a:gd name="adj" fmla="val 6944"/>
+              <a:gd name="adj" fmla="val 9615"/>
             </a:avLst>
           </a:prstGeom>
           <a:solidFill>
@@ -1785,14 +1967,14 @@
       </p:sp>
       <p:sp>
         <p:nvSpPr>
-          <p:cNvPr id="29" name="Highlight Any item"/>
+          <p:cNvPr id="32" name="Highlight Any item"/>
           <p:cNvSpPr txBox="1"/>
           <p:nvPr/>
         </p:nvSpPr>
         <p:spPr>
           <a:xfrm>
-            <a:off x="4921250" y="4714875"/>
-            <a:ext cx="1784350" cy="1181100"/>
+            <a:off x="4921250" y="5105400"/>
+            <a:ext cx="1784350" cy="819150"/>
           </a:xfrm>
           <a:prstGeom prst="rect">
             <a:avLst/>
@@ -1831,7 +2013,7 @@
               <a:buNone/>
             </a:pPr>
             <a:r>
-              <a:rPr lang="en-US" sz="1100" dirty="0">
+              <a:rPr lang="en-US" sz="1150" dirty="0">
                 <a:solidFill>
                   <a:srgbClr val="DDDDDD"/>
                 </a:solidFill>
@@ -1839,7 +2021,7 @@
                 <a:ea typeface="Arial" pitchFamily="34" charset="-122"/>
                 <a:cs typeface="Arial" pitchFamily="34" charset="-120"/>
               </a:rPr>
-              <a:t>custom fields let a violin and an iPad each store what matters</a:t>
+              <a:t>custom fields fit a violin or an iPad</a:t>
             </a:r>
             <a:endParaRPr lang="en-US" sz="2200" dirty="0"/>
           </a:p>
@@ -1847,14 +2029,14 @@
       </p:sp>
       <p:sp>
         <p:nvSpPr>
-          <p:cNvPr id="30" name="Shape 26"/>
+          <p:cNvPr id="33" name="Shape 29"/>
           <p:cNvSpPr/>
           <p:nvPr/>
         </p:nvSpPr>
         <p:spPr>
           <a:xfrm>
-            <a:off x="7219950" y="381000"/>
-            <a:ext cx="4476750" cy="4476750"/>
+            <a:off x="7219950" y="323850"/>
+            <a:ext cx="4476750" cy="4572000"/>
           </a:xfrm>
           <a:prstGeom prst="roundRect">
             <a:avLst>
@@ -1881,13 +2063,13 @@
       </p:sp>
       <p:sp>
         <p:nvSpPr>
-          <p:cNvPr id="31" name="Shape 27"/>
+          <p:cNvPr id="34" name="Shape 30"/>
           <p:cNvSpPr/>
           <p:nvPr/>
         </p:nvSpPr>
         <p:spPr>
           <a:xfrm>
-            <a:off x="7219950" y="381000"/>
+            <a:off x="7219950" y="323850"/>
             <a:ext cx="4476750" cy="247650"/>
           </a:xfrm>
           <a:prstGeom prst="roundRect">
@@ -1908,13 +2090,13 @@
       </p:sp>
       <p:sp>
         <p:nvSpPr>
-          <p:cNvPr id="32" name="Shape 28"/>
+          <p:cNvPr id="35" name="Shape 31"/>
           <p:cNvSpPr/>
           <p:nvPr/>
         </p:nvSpPr>
         <p:spPr>
           <a:xfrm>
-            <a:off x="7219950" y="533400"/>
+            <a:off x="7219950" y="476250"/>
             <a:ext cx="4476750" cy="95250"/>
           </a:xfrm>
           <a:prstGeom prst="rect">
@@ -1933,13 +2115,13 @@
       </p:sp>
       <p:sp>
         <p:nvSpPr>
-          <p:cNvPr id="33" name="Shape 29"/>
+          <p:cNvPr id="36" name="Shape 32"/>
           <p:cNvSpPr/>
           <p:nvPr/>
         </p:nvSpPr>
         <p:spPr>
           <a:xfrm>
-            <a:off x="7315200" y="457200"/>
+            <a:off x="7315200" y="400050"/>
             <a:ext cx="95250" cy="95250"/>
           </a:xfrm>
           <a:prstGeom prst="ellipse">
@@ -1953,13 +2135,13 @@
       </p:sp>
       <p:sp>
         <p:nvSpPr>
-          <p:cNvPr id="34" name="Shape 30"/>
+          <p:cNvPr id="37" name="Shape 33"/>
           <p:cNvSpPr/>
           <p:nvPr/>
         </p:nvSpPr>
         <p:spPr>
           <a:xfrm>
-            <a:off x="7467600" y="457200"/>
+            <a:off x="7467600" y="400050"/>
             <a:ext cx="95250" cy="95250"/>
           </a:xfrm>
           <a:prstGeom prst="ellipse">
@@ -1973,13 +2155,13 @@
       </p:sp>
       <p:sp>
         <p:nvSpPr>
-          <p:cNvPr id="35" name="Shape 31"/>
+          <p:cNvPr id="38" name="Shape 34"/>
           <p:cNvSpPr/>
           <p:nvPr/>
         </p:nvSpPr>
         <p:spPr>
           <a:xfrm>
-            <a:off x="7620000" y="457200"/>
+            <a:off x="7620000" y="400050"/>
             <a:ext cx="95250" cy="95250"/>
           </a:xfrm>
           <a:prstGeom prst="ellipse">
@@ -1993,13 +2175,13 @@
       </p:sp>
       <p:sp>
         <p:nvSpPr>
-          <p:cNvPr id="36" name="Text 32"/>
+          <p:cNvPr id="39" name="Text 35"/>
           <p:cNvSpPr txBox="1"/>
           <p:nvPr/>
         </p:nvSpPr>
         <p:spPr>
           <a:xfrm>
-            <a:off x="7867650" y="419100"/>
+            <a:off x="7867650" y="361950"/>
             <a:ext cx="3714750" cy="171450"/>
           </a:xfrm>
           <a:prstGeom prst="rect">
@@ -2032,7 +2214,7 @@
       </p:sp>
       <p:pic>
         <p:nvPicPr>
-          <p:cNvPr id="37" name="Swagger screenshot" descr="C:\Users\Aaron\AppData\Local\Temp\claude\C--Users-Aaron-Desktop-ict30017-P01-inventory-management-schools\97f81feb-cc42-48d2-a7dc-9fa67447c472\scratchpad\pptx\swagger_top_crop.png">    </p:cNvPr>
+          <p:cNvPr id="40" name="Swagger screenshot" descr="C:\Users\Aaron\AppData\Local\Temp\claude\C--Users-Aaron-Desktop-ict30017-P01-inventory-management-schools\97f81feb-cc42-48d2-a7dc-9fa67447c472\scratchpad\pptx\swagger_top_crop.png">    </p:cNvPr>
           <p:cNvPicPr>
             <a:picLocks noChangeAspect="1"/>
           </p:cNvPicPr>
@@ -2046,8 +2228,8 @@
         </p:blipFill>
         <p:spPr>
           <a:xfrm>
-            <a:off x="7229475" y="628650"/>
-            <a:ext cx="4457700" cy="4219575"/>
+            <a:off x="7229475" y="571500"/>
+            <a:ext cx="4457700" cy="4210050"/>
           </a:xfrm>
           <a:prstGeom prst="rect">
             <a:avLst/>
@@ -2056,13 +2238,13 @@
       </p:pic>
       <p:sp>
         <p:nvSpPr>
-          <p:cNvPr id="38" name="Text 33"/>
+          <p:cNvPr id="41" name="Text 36"/>
           <p:cNvSpPr txBox="1"/>
           <p:nvPr/>
         </p:nvSpPr>
         <p:spPr>
           <a:xfrm>
-            <a:off x="7219950" y="4953000"/>
+            <a:off x="7219950" y="4991100"/>
             <a:ext cx="4476750" cy="190500"/>
           </a:xfrm>
           <a:prstGeom prst="rect">
@@ -2095,13 +2277,13 @@
       </p:sp>
       <p:sp>
         <p:nvSpPr>
-          <p:cNvPr id="39" name="Shape 34"/>
+          <p:cNvPr id="42" name="Shape 37"/>
           <p:cNvSpPr/>
           <p:nvPr/>
         </p:nvSpPr>
         <p:spPr>
           <a:xfrm>
-            <a:off x="7325677" y="5257800"/>
+            <a:off x="7325677" y="5295900"/>
             <a:ext cx="1510665" cy="247650"/>
           </a:xfrm>
           <a:prstGeom prst="roundRect">
@@ -2122,13 +2304,13 @@
       </p:sp>
       <p:sp>
         <p:nvSpPr>
-          <p:cNvPr id="40" name="Text 35"/>
+          <p:cNvPr id="43" name="Text 38"/>
           <p:cNvSpPr txBox="1"/>
           <p:nvPr/>
         </p:nvSpPr>
         <p:spPr>
           <a:xfrm>
-            <a:off x="7325677" y="5257800"/>
+            <a:off x="7325677" y="5295900"/>
             <a:ext cx="1510665" cy="247650"/>
           </a:xfrm>
           <a:prstGeom prst="rect">
@@ -2161,13 +2343,13 @@
       </p:sp>
       <p:sp>
         <p:nvSpPr>
-          <p:cNvPr id="41" name="Shape 36"/>
+          <p:cNvPr id="44" name="Shape 39"/>
           <p:cNvSpPr/>
           <p:nvPr/>
         </p:nvSpPr>
         <p:spPr>
           <a:xfrm>
-            <a:off x="8893492" y="5257800"/>
+            <a:off x="8893492" y="5295900"/>
             <a:ext cx="1447800" cy="247650"/>
           </a:xfrm>
           <a:prstGeom prst="roundRect">
@@ -2188,13 +2370,13 @@
       </p:sp>
       <p:sp>
         <p:nvSpPr>
-          <p:cNvPr id="42" name="Text 37"/>
+          <p:cNvPr id="45" name="Text 40"/>
           <p:cNvSpPr txBox="1"/>
           <p:nvPr/>
         </p:nvSpPr>
         <p:spPr>
           <a:xfrm>
-            <a:off x="8893492" y="5257800"/>
+            <a:off x="8893492" y="5295900"/>
             <a:ext cx="1447800" cy="247650"/>
           </a:xfrm>
           <a:prstGeom prst="rect">
@@ -2227,13 +2409,13 @@
       </p:sp>
       <p:sp>
         <p:nvSpPr>
-          <p:cNvPr id="43" name="Shape 38"/>
+          <p:cNvPr id="46" name="Shape 41"/>
           <p:cNvSpPr/>
           <p:nvPr/>
         </p:nvSpPr>
         <p:spPr>
           <a:xfrm>
-            <a:off x="10398442" y="5257800"/>
+            <a:off x="10398442" y="5295900"/>
             <a:ext cx="567690" cy="247650"/>
           </a:xfrm>
           <a:prstGeom prst="roundRect">
@@ -2254,13 +2436,13 @@
       </p:sp>
       <p:sp>
         <p:nvSpPr>
-          <p:cNvPr id="44" name="Text 39"/>
+          <p:cNvPr id="47" name="Text 42"/>
           <p:cNvSpPr txBox="1"/>
           <p:nvPr/>
         </p:nvSpPr>
         <p:spPr>
           <a:xfrm>
-            <a:off x="10398442" y="5257800"/>
+            <a:off x="10398442" y="5295900"/>
             <a:ext cx="567690" cy="247650"/>
           </a:xfrm>
           <a:prstGeom prst="rect">
@@ -2293,13 +2475,13 @@
       </p:sp>
       <p:sp>
         <p:nvSpPr>
-          <p:cNvPr id="45" name="Shape 40"/>
+          <p:cNvPr id="48" name="Shape 43"/>
           <p:cNvSpPr/>
           <p:nvPr/>
         </p:nvSpPr>
         <p:spPr>
           <a:xfrm>
-            <a:off x="11023282" y="5257800"/>
+            <a:off x="11023282" y="5295900"/>
             <a:ext cx="567690" cy="247650"/>
           </a:xfrm>
           <a:prstGeom prst="roundRect">
@@ -2320,13 +2502,13 @@
       </p:sp>
       <p:sp>
         <p:nvSpPr>
-          <p:cNvPr id="46" name="Text 41"/>
+          <p:cNvPr id="49" name="Text 44"/>
           <p:cNvSpPr txBox="1"/>
           <p:nvPr/>
         </p:nvSpPr>
         <p:spPr>
           <a:xfrm>
-            <a:off x="11023282" y="5257800"/>
+            <a:off x="11023282" y="5295900"/>
             <a:ext cx="567690" cy="247650"/>
           </a:xfrm>
           <a:prstGeom prst="rect">
@@ -2359,13 +2541,13 @@
       </p:sp>
       <p:sp>
         <p:nvSpPr>
-          <p:cNvPr id="47" name="Shape 42"/>
+          <p:cNvPr id="50" name="Shape 45"/>
           <p:cNvSpPr/>
           <p:nvPr/>
         </p:nvSpPr>
         <p:spPr>
           <a:xfrm>
-            <a:off x="8891588" y="5572125"/>
+            <a:off x="8891588" y="5610225"/>
             <a:ext cx="1133475" cy="247650"/>
           </a:xfrm>
           <a:prstGeom prst="roundRect">
@@ -2386,13 +2568,13 @@
       </p:sp>
       <p:sp>
         <p:nvSpPr>
-          <p:cNvPr id="48" name="Text 43"/>
+          <p:cNvPr id="51" name="Text 46"/>
           <p:cNvSpPr txBox="1"/>
           <p:nvPr/>
         </p:nvSpPr>
         <p:spPr>
           <a:xfrm>
-            <a:off x="8891588" y="5572125"/>
+            <a:off x="8891588" y="5610225"/>
             <a:ext cx="1133475" cy="247650"/>
           </a:xfrm>
           <a:prstGeom prst="rect">
@@ -2425,13 +2607,13 @@
       </p:sp>
       <p:sp>
         <p:nvSpPr>
-          <p:cNvPr id="49" name="Text 44"/>
+          <p:cNvPr id="52" name="Text 47"/>
           <p:cNvSpPr txBox="1"/>
           <p:nvPr/>
         </p:nvSpPr>
         <p:spPr>
           <a:xfrm>
-            <a:off x="495300" y="6534150"/>
+            <a:off x="495300" y="6477000"/>
             <a:ext cx="4762500" cy="171450"/>
           </a:xfrm>
           <a:prstGeom prst="rect">
@@ -2464,13 +2646,13 @@
       </p:sp>
       <p:sp>
         <p:nvSpPr>
-          <p:cNvPr id="50" name="Text 45"/>
+          <p:cNvPr id="53" name="Text 48"/>
           <p:cNvSpPr txBox="1"/>
           <p:nvPr/>
         </p:nvSpPr>
         <p:spPr>
           <a:xfrm>
-            <a:off x="8572500" y="6534150"/>
+            <a:off x="8572500" y="6477000"/>
             <a:ext cx="3124200" cy="171450"/>
           </a:xfrm>
           <a:prstGeom prst="rect">

</xml_diff>